<commit_message>
repo: remove duplicate web/ tree (the live app = prototype/web; the copy was a publish-script cwd bug artifact)
</commit_message>
<xml_diff>
--- a/prototype/presentation/QueryGuard_SRS.pptx
+++ b/prototype/presentation/QueryGuard_SRS.pptx
@@ -4849,7 +4849,7 @@
                 </a:solidFill>
                 <a:latin typeface="Segoe UI"/>
               </a:rPr>
-              <a:t>I want asks a question and sees an answer</a:t>
+              <a:t>I want to ask a question and see an answer</a:t>
             </a:r>
           </a:p>
         </p:txBody>
@@ -4884,7 +4884,7 @@
                 </a:solidFill>
                 <a:latin typeface="Segoe UI"/>
               </a:rPr>
-              <a:t>so that sees the product work end to end</a:t>
+              <a:t>so that the product works end to end</a:t>
             </a:r>
           </a:p>
         </p:txBody>
@@ -5000,7 +5000,7 @@
                 </a:solidFill>
                 <a:latin typeface="Segoe UI"/>
               </a:rPr>
-              <a:t>I want knows SSNs can never appear in answers</a:t>
+              <a:t>I want to know SSNs can never appear in answers</a:t>
             </a:r>
           </a:p>
         </p:txBody>
@@ -5035,7 +5035,7 @@
                 </a:solidFill>
                 <a:latin typeface="Segoe UI"/>
               </a:rPr>
-              <a:t>so that believes the privacy claim</a:t>
+              <a:t>so that the privacy claim is believed</a:t>
             </a:r>
           </a:p>
         </p:txBody>
@@ -5151,7 +5151,7 @@
                 </a:solidFill>
                 <a:latin typeface="Segoe UI"/>
               </a:rPr>
-              <a:t>I want browses a log of every decision</a:t>
+              <a:t>I want to browse a log of every decision</a:t>
             </a:r>
           </a:p>
         </p:txBody>
@@ -5186,7 +5186,7 @@
                 </a:solidFill>
                 <a:latin typeface="Segoe UI"/>
               </a:rPr>
-              <a:t>so that can verify what ran and why, later</a:t>
+              <a:t>so that what ran and why is verifiable later</a:t>
             </a:r>
           </a:p>
         </p:txBody>
@@ -5302,7 +5302,7 @@
                 </a:solidFill>
                 <a:latin typeface="Segoe UI"/>
               </a:rPr>
-              <a:t>I want runs one command against known attacks</a:t>
+              <a:t>I want to run one command against known attacks</a:t>
             </a:r>
           </a:p>
         </p:txBody>

</xml_diff>